<commit_message>
Use official BugBoundQA logo, brand colors and speaker photo in CV session deck
Co-Authored-By: Claude Opus 5.5 <noreply@anthropic.com>
Claude-Session: https://claude.ai/code/session_014BXfC45HZkZW1w6WP4YsuA
</commit_message>
<xml_diff>
--- a/presentations/CV_Writing_for_Freshers_BugBoundQA.pptx
+++ b/presentations/CV_Writing_for_Freshers_BugBoundQA.pptx
@@ -125,7 +125,7 @@
   <p:extLst>
     <p:ext uri="{521415D9-36F7-43E2-AB2F-B90AF26B5E84}">
       <p14:sectionLst xmlns:p14="http://schemas.microsoft.com/office/powerpoint/2010/main">
-        <p14:section name="Welcome" id="{295a797f-a74c-0f2b-eb7e-c116e9b2a87f}">
+        <p14:section name="Welcome" id="{a7dc46c4-ce20-b4a0-1bea-f460971a10ba}">
           <p14:sldIdLst>
             <p14:sldId id="256"/>
             <p14:sldId id="257"/>
@@ -134,7 +134,7 @@
             <p14:sldId id="260"/>
           </p14:sldIdLst>
         </p14:section>
-        <p14:section name="Building Your CV" id="{40ebc860-6f56-4914-ee42-4f3ae9d3ad5e}">
+        <p14:section name="Building Your CV" id="{49510f5c-b92f-18e4-5347-e1d01331fe59}">
           <p14:sldIdLst>
             <p14:sldId id="261"/>
             <p14:sldId id="262"/>
@@ -146,7 +146,7 @@
             <p14:sldId id="268"/>
           </p14:sldIdLst>
         </p14:section>
-        <p14:section name="Getting Shortlisted" id="{3ffb83c0-2c24-78ad-10a5-def74e1e3de2}">
+        <p14:section name="Getting Shortlisted" id="{11f37728-30f9-3741-d298-29dbdba15552}">
           <p14:sldIdLst>
             <p14:sldId id="269"/>
             <p14:sldId id="270"/>
@@ -154,7 +154,7 @@
             <p14:sldId id="272"/>
           </p14:sldIdLst>
         </p14:section>
-        <p14:section name="Wrap-up" id="{92344b24-c7d9-8ad8-cdbb-f767d556e25f}">
+        <p14:section name="Wrap-up" id="{bb096ce5-fe41-e84f-a2c4-b5b7e4a906b8}">
           <p14:sldIdLst>
             <p14:sldId id="273"/>
             <p14:sldId id="274"/>
@@ -2260,8 +2260,8 @@
         </p:blipFill>
         <p:spPr>
           <a:xfrm>
-            <a:off x="548640" y="502920"/>
-            <a:ext cx="2857500" cy="685800"/>
+            <a:off x="548640" y="411480"/>
+            <a:ext cx="1951561" cy="1051560"/>
           </a:xfrm>
           <a:prstGeom prst="rect">
             <a:avLst/>
@@ -2279,7 +2279,7 @@
         <p:spPr>
           <a:xfrm>
             <a:off x="548640" y="1920240"/>
-            <a:ext cx="8412480" cy="2011680"/>
+            <a:ext cx="7589520" cy="2011680"/>
           </a:xfrm>
           <a:prstGeom prst="rect">
             <a:avLst/>
@@ -2318,7 +2318,7 @@
         <p:spPr>
           <a:xfrm>
             <a:off x="548640" y="4069080"/>
-            <a:ext cx="8412480" cy="548640"/>
+            <a:ext cx="7589520" cy="548640"/>
           </a:xfrm>
           <a:prstGeom prst="rect">
             <a:avLst/>
@@ -2394,8 +2394,8 @@
         </p:blipFill>
         <p:spPr>
           <a:xfrm>
-            <a:off x="548640" y="5989320"/>
-            <a:ext cx="1714500" cy="411480"/>
+            <a:off x="548640" y="5715000"/>
+            <a:ext cx="1272757" cy="685800"/>
           </a:xfrm>
           <a:prstGeom prst="rect">
             <a:avLst/>
@@ -2573,8 +2573,8 @@
         </p:blipFill>
         <p:spPr>
           <a:xfrm>
-            <a:off x="10042855" y="457200"/>
-            <a:ext cx="1600200" cy="384048"/>
+            <a:off x="10422608" y="320040"/>
+            <a:ext cx="1357607" cy="731520"/>
           </a:xfrm>
           <a:prstGeom prst="rect">
             <a:avLst/>
@@ -3062,7 +3062,7 @@
         <p:spPr>
           <a:xfrm>
             <a:off x="548640" y="1920240"/>
-            <a:ext cx="8412480" cy="2011680"/>
+            <a:ext cx="7589520" cy="2011680"/>
           </a:xfrm>
           <a:prstGeom prst="rect">
             <a:avLst/>
@@ -3100,7 +3100,7 @@
         <p:spPr>
           <a:xfrm>
             <a:off x="548640" y="4069080"/>
-            <a:ext cx="8412480" cy="548640"/>
+            <a:ext cx="7589520" cy="548640"/>
           </a:xfrm>
           <a:prstGeom prst="rect">
             <a:avLst/>
@@ -3235,27 +3235,27 @@
       </p:sp>
       <p:sp>
         <p:nvSpPr>
-          <p:cNvPr id="6" name="Decor circle"/>
+          <p:cNvPr id="6" name="Photo ring"/>
           <p:cNvSpPr/>
           <p:nvPr/>
         </p:nvSpPr>
         <p:spPr>
           <a:xfrm>
-            <a:off x="9052560" y="1280160"/>
-            <a:ext cx="4206240" cy="4206240"/>
+            <a:off x="8366760" y="1234440"/>
+            <a:ext cx="3474720" cy="3474720"/>
           </a:xfrm>
           <a:prstGeom prst="ellipse">
             <a:avLst/>
           </a:prstGeom>
           <a:solidFill>
-            <a:schemeClr val="accent1"/>
+            <a:schemeClr val="accent2"/>
           </a:solidFill>
           <a:ln/>
         </p:spPr>
       </p:sp>
       <p:pic>
         <p:nvPicPr>
-          <p:cNvPr id="7" name="CV icon" descr="CV document icon">    </p:cNvPr>
+          <p:cNvPr id="7" name="Speaker photo" descr="Jannatul Ferdous Katha">    </p:cNvPr>
           <p:cNvPicPr>
             <a:picLocks noChangeAspect="1"/>
           </p:cNvPicPr>
@@ -3269,8 +3269,8 @@
         </p:blipFill>
         <p:spPr>
           <a:xfrm>
-            <a:off x="10058400" y="2331720"/>
-            <a:ext cx="2103120" cy="2103120"/>
+            <a:off x="8503920" y="1371600"/>
+            <a:ext cx="3200400" cy="3200400"/>
           </a:xfrm>
           <a:prstGeom prst="rect">
             <a:avLst/>
@@ -4604,7 +4604,7 @@
           <a:ln/>
           <a:effectLst>
             <a:outerShdw sx="100000" sy="100000" kx="0" ky="0" algn="bl" rotWithShape="0" blurRad="101600" dist="25400" dir="5400000">
-              <a:srgbClr val="1B2A41">
+              <a:srgbClr val="0E2240">
                 <a:alpha val="12000"/>
               </a:srgbClr>
             </a:outerShdw>
@@ -5128,7 +5128,7 @@
           <a:ln/>
           <a:effectLst>
             <a:outerShdw sx="100000" sy="100000" kx="0" ky="0" algn="bl" rotWithShape="0" blurRad="101600" dist="25400" dir="5400000">
-              <a:srgbClr val="1B2A41">
+              <a:srgbClr val="0E2240">
                 <a:alpha val="12000"/>
               </a:srgbClr>
             </a:outerShdw>
@@ -5162,7 +5162,7 @@
             <a:r>
               <a:rPr lang="en-US" sz="1500" b="1" dirty="0">
                 <a:solidFill>
-                  <a:schemeClr val="accent1"/>
+                  <a:schemeClr val="accent5"/>
                 </a:solidFill>
               </a:rPr>
               <a:t>Before</a:t>
@@ -5231,7 +5231,7 @@
           <a:ln/>
           <a:effectLst>
             <a:outerShdw sx="100000" sy="100000" kx="0" ky="0" algn="bl" rotWithShape="0" blurRad="101600" dist="25400" dir="5400000">
-              <a:srgbClr val="1B2A41">
+              <a:srgbClr val="0E2240">
                 <a:alpha val="12000"/>
               </a:srgbClr>
             </a:outerShdw>
@@ -5310,7 +5310,7 @@
           <a:ln/>
           <a:effectLst>
             <a:outerShdw sx="100000" sy="100000" kx="0" ky="0" algn="bl" rotWithShape="0" blurRad="101600" dist="25400" dir="5400000">
-              <a:srgbClr val="1B2A41">
+              <a:srgbClr val="0E2240">
                 <a:alpha val="12000"/>
               </a:srgbClr>
             </a:outerShdw>
@@ -5344,7 +5344,7 @@
             <a:r>
               <a:rPr lang="en-US" sz="1500" b="1" dirty="0">
                 <a:solidFill>
-                  <a:schemeClr val="accent1"/>
+                  <a:schemeClr val="accent5"/>
                 </a:solidFill>
               </a:rPr>
               <a:t>Before</a:t>
@@ -5413,7 +5413,7 @@
           <a:ln/>
           <a:effectLst>
             <a:outerShdw sx="100000" sy="100000" kx="0" ky="0" algn="bl" rotWithShape="0" blurRad="101600" dist="25400" dir="5400000">
-              <a:srgbClr val="1B2A41">
+              <a:srgbClr val="0E2240">
                 <a:alpha val="12000"/>
               </a:srgbClr>
             </a:outerShdw>
@@ -5600,7 +5600,7 @@
           <a:ln/>
           <a:effectLst>
             <a:outerShdw sx="100000" sy="100000" kx="0" ky="0" algn="bl" rotWithShape="0" blurRad="101600" dist="25400" dir="5400000">
-              <a:srgbClr val="1B2A41">
+              <a:srgbClr val="0E2240">
                 <a:alpha val="12000"/>
               </a:srgbClr>
             </a:outerShdw>
@@ -5745,7 +5745,7 @@
           <a:ln/>
           <a:effectLst>
             <a:outerShdw sx="100000" sy="100000" kx="0" ky="0" algn="bl" rotWithShape="0" blurRad="101600" dist="25400" dir="5400000">
-              <a:srgbClr val="1B2A41">
+              <a:srgbClr val="0E2240">
                 <a:alpha val="12000"/>
               </a:srgbClr>
             </a:outerShdw>
@@ -5890,7 +5890,7 @@
           <a:ln/>
           <a:effectLst>
             <a:outerShdw sx="100000" sy="100000" kx="0" ky="0" algn="bl" rotWithShape="0" blurRad="101600" dist="25400" dir="5400000">
-              <a:srgbClr val="1B2A41">
+              <a:srgbClr val="0E2240">
                 <a:alpha val="12000"/>
               </a:srgbClr>
             </a:outerShdw>
@@ -6035,7 +6035,7 @@
           <a:ln/>
           <a:effectLst>
             <a:outerShdw sx="100000" sy="100000" kx="0" ky="0" algn="bl" rotWithShape="0" blurRad="101600" dist="25400" dir="5400000">
-              <a:srgbClr val="1B2A41">
+              <a:srgbClr val="0E2240">
                 <a:alpha val="12000"/>
               </a:srgbClr>
             </a:outerShdw>
@@ -6180,7 +6180,7 @@
           <a:ln/>
           <a:effectLst>
             <a:outerShdw sx="100000" sy="100000" kx="0" ky="0" algn="bl" rotWithShape="0" blurRad="101600" dist="25400" dir="5400000">
-              <a:srgbClr val="1B2A41">
+              <a:srgbClr val="0E2240">
                 <a:alpha val="12000"/>
               </a:srgbClr>
             </a:outerShdw>
@@ -6325,7 +6325,7 @@
           <a:ln/>
           <a:effectLst>
             <a:outerShdw sx="100000" sy="100000" kx="0" ky="0" algn="bl" rotWithShape="0" blurRad="101600" dist="25400" dir="5400000">
-              <a:srgbClr val="1B2A41">
+              <a:srgbClr val="0E2240">
                 <a:alpha val="12000"/>
               </a:srgbClr>
             </a:outerShdw>
@@ -6347,7 +6347,7 @@
             <a:avLst/>
           </a:prstGeom>
           <a:solidFill>
-            <a:schemeClr val="accent5"/>
+            <a:schemeClr val="tx2"/>
           </a:solidFill>
           <a:ln/>
         </p:spPr>
@@ -7289,7 +7289,7 @@
             <a:avLst/>
           </a:prstGeom>
           <a:solidFill>
-            <a:schemeClr val="accent5"/>
+            <a:schemeClr val="tx1"/>
           </a:solidFill>
           <a:ln/>
         </p:spPr>
@@ -7376,7 +7376,7 @@
           <a:ln/>
           <a:effectLst>
             <a:outerShdw sx="100000" sy="100000" kx="0" ky="0" algn="bl" rotWithShape="0" blurRad="101600" dist="25400" dir="5400000">
-              <a:srgbClr val="1B2A41">
+              <a:srgbClr val="0E2240">
                 <a:alpha val="12000"/>
               </a:srgbClr>
             </a:outerShdw>
@@ -7597,7 +7597,7 @@
           <a:ln/>
           <a:effectLst>
             <a:outerShdw sx="100000" sy="100000" kx="0" ky="0" algn="bl" rotWithShape="0" blurRad="101600" dist="25400" dir="5400000">
-              <a:srgbClr val="1B2A41">
+              <a:srgbClr val="0E2240">
                 <a:alpha val="12000"/>
               </a:srgbClr>
             </a:outerShdw>
@@ -7619,7 +7619,7 @@
             <a:avLst/>
           </a:prstGeom>
           <a:solidFill>
-            <a:schemeClr val="accent1"/>
+            <a:schemeClr val="accent5"/>
           </a:solidFill>
           <a:ln/>
         </p:spPr>
@@ -7675,7 +7675,7 @@
             <a:r>
               <a:rPr lang="en-US" sz="2000" b="1" dirty="0">
                 <a:solidFill>
-                  <a:schemeClr val="accent1"/>
+                  <a:schemeClr val="accent5"/>
                 </a:solidFill>
               </a:rPr>
               <a:t>Avoid</a:t>
@@ -8606,7 +8606,7 @@
           <a:ln/>
           <a:effectLst>
             <a:outerShdw sx="100000" sy="100000" kx="0" ky="0" algn="bl" rotWithShape="0" blurRad="101600" dist="25400" dir="5400000">
-              <a:srgbClr val="1B2A41">
+              <a:srgbClr val="0E2240">
                 <a:alpha val="12000"/>
               </a:srgbClr>
             </a:outerShdw>
@@ -8790,7 +8790,7 @@
           <a:ln/>
           <a:effectLst>
             <a:outerShdw sx="100000" sy="100000" kx="0" ky="0" algn="bl" rotWithShape="0" blurRad="101600" dist="25400" dir="5400000">
-              <a:srgbClr val="1B2A41">
+              <a:srgbClr val="0E2240">
                 <a:alpha val="12000"/>
               </a:srgbClr>
             </a:outerShdw>
@@ -8812,7 +8812,7 @@
             <a:avLst/>
           </a:prstGeom>
           <a:solidFill>
-            <a:schemeClr val="accent1"/>
+            <a:schemeClr val="accent5"/>
           </a:solidFill>
           <a:ln/>
         </p:spPr>
@@ -8935,7 +8935,7 @@
           <a:ln/>
           <a:effectLst>
             <a:outerShdw sx="100000" sy="100000" kx="0" ky="0" algn="bl" rotWithShape="0" blurRad="101600" dist="25400" dir="5400000">
-              <a:srgbClr val="1B2A41">
+              <a:srgbClr val="0E2240">
                 <a:alpha val="12000"/>
               </a:srgbClr>
             </a:outerShdw>
@@ -8957,7 +8957,7 @@
             <a:avLst/>
           </a:prstGeom>
           <a:solidFill>
-            <a:schemeClr val="accent1"/>
+            <a:schemeClr val="accent5"/>
           </a:solidFill>
           <a:ln/>
         </p:spPr>
@@ -9080,7 +9080,7 @@
           <a:ln/>
           <a:effectLst>
             <a:outerShdw sx="100000" sy="100000" kx="0" ky="0" algn="bl" rotWithShape="0" blurRad="101600" dist="25400" dir="5400000">
-              <a:srgbClr val="1B2A41">
+              <a:srgbClr val="0E2240">
                 <a:alpha val="12000"/>
               </a:srgbClr>
             </a:outerShdw>
@@ -9102,7 +9102,7 @@
             <a:avLst/>
           </a:prstGeom>
           <a:solidFill>
-            <a:schemeClr val="accent1"/>
+            <a:schemeClr val="accent5"/>
           </a:solidFill>
           <a:ln/>
         </p:spPr>
@@ -9225,7 +9225,7 @@
           <a:ln/>
           <a:effectLst>
             <a:outerShdw sx="100000" sy="100000" kx="0" ky="0" algn="bl" rotWithShape="0" blurRad="101600" dist="25400" dir="5400000">
-              <a:srgbClr val="1B2A41">
+              <a:srgbClr val="0E2240">
                 <a:alpha val="12000"/>
               </a:srgbClr>
             </a:outerShdw>
@@ -9247,7 +9247,7 @@
             <a:avLst/>
           </a:prstGeom>
           <a:solidFill>
-            <a:schemeClr val="accent1"/>
+            <a:schemeClr val="accent5"/>
           </a:solidFill>
           <a:ln/>
         </p:spPr>
@@ -9370,7 +9370,7 @@
           <a:ln/>
           <a:effectLst>
             <a:outerShdw sx="100000" sy="100000" kx="0" ky="0" algn="bl" rotWithShape="0" blurRad="101600" dist="25400" dir="5400000">
-              <a:srgbClr val="1B2A41">
+              <a:srgbClr val="0E2240">
                 <a:alpha val="12000"/>
               </a:srgbClr>
             </a:outerShdw>
@@ -9392,7 +9392,7 @@
             <a:avLst/>
           </a:prstGeom>
           <a:solidFill>
-            <a:schemeClr val="accent1"/>
+            <a:schemeClr val="accent5"/>
           </a:solidFill>
           <a:ln/>
         </p:spPr>
@@ -9515,7 +9515,7 @@
           <a:ln/>
           <a:effectLst>
             <a:outerShdw sx="100000" sy="100000" kx="0" ky="0" algn="bl" rotWithShape="0" blurRad="101600" dist="25400" dir="5400000">
-              <a:srgbClr val="1B2A41">
+              <a:srgbClr val="0E2240">
                 <a:alpha val="12000"/>
               </a:srgbClr>
             </a:outerShdw>
@@ -9537,7 +9537,7 @@
             <a:avLst/>
           </a:prstGeom>
           <a:solidFill>
-            <a:schemeClr val="accent1"/>
+            <a:schemeClr val="accent5"/>
           </a:solidFill>
           <a:ln/>
         </p:spPr>
@@ -10627,7 +10627,7 @@
         <p:spPr>
           <a:xfrm>
             <a:off x="548640" y="1920240"/>
-            <a:ext cx="8412480" cy="2011680"/>
+            <a:ext cx="7589520" cy="2011680"/>
           </a:xfrm>
           <a:prstGeom prst="rect">
             <a:avLst/>
@@ -10665,7 +10665,7 @@
         <p:spPr>
           <a:xfrm>
             <a:off x="548640" y="4069080"/>
-            <a:ext cx="8412480" cy="548640"/>
+            <a:ext cx="7589520" cy="548640"/>
           </a:xfrm>
           <a:prstGeom prst="rect">
             <a:avLst/>
@@ -10913,7 +10913,7 @@
           <a:ln/>
           <a:effectLst>
             <a:outerShdw sx="100000" sy="100000" kx="0" ky="0" algn="bl" rotWithShape="0" blurRad="101600" dist="25400" dir="5400000">
-              <a:srgbClr val="1B2A41">
+              <a:srgbClr val="0E2240">
                 <a:alpha val="12000"/>
               </a:srgbClr>
             </a:outerShdw>
@@ -10922,14 +10922,14 @@
       </p:sp>
       <p:sp>
         <p:nvSpPr>
-          <p:cNvPr id="4" name="Speaker circle"/>
+          <p:cNvPr id="4" name="Photo ring"/>
           <p:cNvSpPr/>
           <p:nvPr/>
         </p:nvSpPr>
         <p:spPr>
           <a:xfrm>
-            <a:off x="1188720" y="2240280"/>
-            <a:ext cx="2377440" cy="2377440"/>
+            <a:off x="1051560" y="2011680"/>
+            <a:ext cx="2651760" cy="2651760"/>
           </a:xfrm>
           <a:prstGeom prst="ellipse">
             <a:avLst/>
@@ -10942,7 +10942,7 @@
       </p:sp>
       <p:pic>
         <p:nvPicPr>
-          <p:cNvPr id="5" name="Speaker icon" descr="Speaker">    </p:cNvPr>
+          <p:cNvPr id="5" name="Speaker photo" descr="Jannatul Ferdous Katha">    </p:cNvPr>
           <p:cNvPicPr>
             <a:picLocks noChangeAspect="1"/>
           </p:cNvPicPr>
@@ -10956,8 +10956,8 @@
         </p:blipFill>
         <p:spPr>
           <a:xfrm>
-            <a:off x="1783080" y="2834640"/>
-            <a:ext cx="1188720" cy="1188720"/>
+            <a:off x="1161288" y="2121408"/>
+            <a:ext cx="2432304" cy="2432304"/>
           </a:xfrm>
           <a:prstGeom prst="rect">
             <a:avLst/>
@@ -11373,7 +11373,7 @@
           <a:ln/>
           <a:effectLst>
             <a:outerShdw sx="100000" sy="100000" kx="0" ky="0" algn="bl" rotWithShape="0" blurRad="101600" dist="25400" dir="5400000">
-              <a:srgbClr val="1B2A41">
+              <a:srgbClr val="0E2240">
                 <a:alpha val="12000"/>
               </a:srgbClr>
             </a:outerShdw>
@@ -11494,7 +11494,7 @@
           <a:ln/>
           <a:effectLst>
             <a:outerShdw sx="100000" sy="100000" kx="0" ky="0" algn="bl" rotWithShape="0" blurRad="101600" dist="25400" dir="5400000">
-              <a:srgbClr val="1B2A41">
+              <a:srgbClr val="0E2240">
                 <a:alpha val="12000"/>
               </a:srgbClr>
             </a:outerShdw>
@@ -11615,7 +11615,7 @@
           <a:ln/>
           <a:effectLst>
             <a:outerShdw sx="100000" sy="100000" kx="0" ky="0" algn="bl" rotWithShape="0" blurRad="101600" dist="25400" dir="5400000">
-              <a:srgbClr val="1B2A41">
+              <a:srgbClr val="0E2240">
                 <a:alpha val="12000"/>
               </a:srgbClr>
             </a:outerShdw>
@@ -11736,7 +11736,7 @@
           <a:ln/>
           <a:effectLst>
             <a:outerShdw sx="100000" sy="100000" kx="0" ky="0" algn="bl" rotWithShape="0" blurRad="101600" dist="25400" dir="5400000">
-              <a:srgbClr val="1B2A41">
+              <a:srgbClr val="0E2240">
                 <a:alpha val="12000"/>
               </a:srgbClr>
             </a:outerShdw>
@@ -11857,7 +11857,7 @@
           <a:ln/>
           <a:effectLst>
             <a:outerShdw sx="100000" sy="100000" kx="0" ky="0" algn="bl" rotWithShape="0" blurRad="101600" dist="25400" dir="5400000">
-              <a:srgbClr val="1B2A41">
+              <a:srgbClr val="0E2240">
                 <a:alpha val="12000"/>
               </a:srgbClr>
             </a:outerShdw>
@@ -11978,7 +11978,7 @@
           <a:ln/>
           <a:effectLst>
             <a:outerShdw sx="100000" sy="100000" kx="0" ky="0" algn="bl" rotWithShape="0" blurRad="101600" dist="25400" dir="5400000">
-              <a:srgbClr val="1B2A41">
+              <a:srgbClr val="0E2240">
                 <a:alpha val="12000"/>
               </a:srgbClr>
             </a:outerShdw>
@@ -12099,7 +12099,7 @@
           <a:ln/>
           <a:effectLst>
             <a:outerShdw sx="100000" sy="100000" kx="0" ky="0" algn="bl" rotWithShape="0" blurRad="101600" dist="25400" dir="5400000">
-              <a:srgbClr val="1B2A41">
+              <a:srgbClr val="0E2240">
                 <a:alpha val="12000"/>
               </a:srgbClr>
             </a:outerShdw>
@@ -12220,7 +12220,7 @@
           <a:ln/>
           <a:effectLst>
             <a:outerShdw sx="100000" sy="100000" kx="0" ky="0" algn="bl" rotWithShape="0" blurRad="101600" dist="25400" dir="5400000">
-              <a:srgbClr val="1B2A41">
+              <a:srgbClr val="0E2240">
                 <a:alpha val="12000"/>
               </a:srgbClr>
             </a:outerShdw>
@@ -12449,7 +12449,7 @@
           <a:ln/>
           <a:effectLst>
             <a:outerShdw sx="100000" sy="100000" kx="0" ky="0" algn="bl" rotWithShape="0" blurRad="101600" dist="25400" dir="5400000">
-              <a:srgbClr val="1B2A41">
+              <a:srgbClr val="0E2240">
                 <a:alpha val="12000"/>
               </a:srgbClr>
             </a:outerShdw>
@@ -12597,7 +12597,7 @@
           <a:ln/>
           <a:effectLst>
             <a:outerShdw sx="100000" sy="100000" kx="0" ky="0" algn="bl" rotWithShape="0" blurRad="101600" dist="25400" dir="5400000">
-              <a:srgbClr val="1B2A41">
+              <a:srgbClr val="0E2240">
                 <a:alpha val="12000"/>
               </a:srgbClr>
             </a:outerShdw>
@@ -12745,7 +12745,7 @@
           <a:ln/>
           <a:effectLst>
             <a:outerShdw sx="100000" sy="100000" kx="0" ky="0" algn="bl" rotWithShape="0" blurRad="101600" dist="25400" dir="5400000">
-              <a:srgbClr val="1B2A41">
+              <a:srgbClr val="0E2240">
                 <a:alpha val="12000"/>
               </a:srgbClr>
             </a:outerShdw>
@@ -13037,7 +13037,7 @@
           <a:ln/>
           <a:effectLst>
             <a:outerShdw sx="100000" sy="100000" kx="0" ky="0" algn="bl" rotWithShape="0" blurRad="101600" dist="25400" dir="5400000">
-              <a:srgbClr val="1B2A41">
+              <a:srgbClr val="0E2240">
                 <a:alpha val="12000"/>
               </a:srgbClr>
             </a:outerShdw>
@@ -13251,7 +13251,7 @@
           <a:ln/>
           <a:effectLst>
             <a:outerShdw sx="100000" sy="100000" kx="0" ky="0" algn="bl" rotWithShape="0" blurRad="101600" dist="25400" dir="5400000">
-              <a:srgbClr val="1B2A41">
+              <a:srgbClr val="0E2240">
                 <a:alpha val="12000"/>
               </a:srgbClr>
             </a:outerShdw>
@@ -13465,7 +13465,7 @@
           <a:ln/>
           <a:effectLst>
             <a:outerShdw sx="100000" sy="100000" kx="0" ky="0" algn="bl" rotWithShape="0" blurRad="101600" dist="25400" dir="5400000">
-              <a:srgbClr val="1B2A41">
+              <a:srgbClr val="0E2240">
                 <a:alpha val="12000"/>
               </a:srgbClr>
             </a:outerShdw>
@@ -13933,7 +13933,7 @@
           <a:ln/>
           <a:effectLst>
             <a:outerShdw sx="100000" sy="100000" kx="0" ky="0" algn="bl" rotWithShape="0" blurRad="101600" dist="25400" dir="5400000">
-              <a:srgbClr val="1B2A41">
+              <a:srgbClr val="0E2240">
                 <a:alpha val="12000"/>
               </a:srgbClr>
             </a:outerShdw>
@@ -14073,7 +14073,7 @@
           <a:ln/>
           <a:effectLst>
             <a:outerShdw sx="100000" sy="100000" kx="0" ky="0" algn="bl" rotWithShape="0" blurRad="101600" dist="25400" dir="5400000">
-              <a:srgbClr val="1B2A41">
+              <a:srgbClr val="0E2240">
                 <a:alpha val="12000"/>
               </a:srgbClr>
             </a:outerShdw>
@@ -14213,7 +14213,7 @@
           <a:ln/>
           <a:effectLst>
             <a:outerShdw sx="100000" sy="100000" kx="0" ky="0" algn="bl" rotWithShape="0" blurRad="101600" dist="25400" dir="5400000">
-              <a:srgbClr val="1B2A41">
+              <a:srgbClr val="0E2240">
                 <a:alpha val="12000"/>
               </a:srgbClr>
             </a:outerShdw>
@@ -14353,7 +14353,7 @@
           <a:ln/>
           <a:effectLst>
             <a:outerShdw sx="100000" sy="100000" kx="0" ky="0" algn="bl" rotWithShape="0" blurRad="101600" dist="25400" dir="5400000">
-              <a:srgbClr val="1B2A41">
+              <a:srgbClr val="0E2240">
                 <a:alpha val="12000"/>
               </a:srgbClr>
             </a:outerShdw>
@@ -14493,7 +14493,7 @@
           <a:ln/>
           <a:effectLst>
             <a:outerShdw sx="100000" sy="100000" kx="0" ky="0" algn="bl" rotWithShape="0" blurRad="101600" dist="25400" dir="5400000">
-              <a:srgbClr val="1B2A41">
+              <a:srgbClr val="0E2240">
                 <a:alpha val="12000"/>
               </a:srgbClr>
             </a:outerShdw>
@@ -14633,7 +14633,7 @@
           <a:ln/>
           <a:effectLst>
             <a:outerShdw sx="100000" sy="100000" kx="0" ky="0" algn="bl" rotWithShape="0" blurRad="101600" dist="25400" dir="5400000">
-              <a:srgbClr val="1B2A41">
+              <a:srgbClr val="0E2240">
                 <a:alpha val="12000"/>
               </a:srgbClr>
             </a:outerShdw>
@@ -14773,7 +14773,7 @@
           <a:ln/>
           <a:effectLst>
             <a:outerShdw sx="100000" sy="100000" kx="0" ky="0" algn="bl" rotWithShape="0" blurRad="101600" dist="25400" dir="5400000">
-              <a:srgbClr val="1B2A41">
+              <a:srgbClr val="0E2240">
                 <a:alpha val="12000"/>
               </a:srgbClr>
             </a:outerShdw>
@@ -14913,7 +14913,7 @@
           <a:ln/>
           <a:effectLst>
             <a:outerShdw sx="100000" sy="100000" kx="0" ky="0" algn="bl" rotWithShape="0" blurRad="101600" dist="25400" dir="5400000">
-              <a:srgbClr val="1B2A41">
+              <a:srgbClr val="0E2240">
                 <a:alpha val="12000"/>
               </a:srgbClr>
             </a:outerShdw>
@@ -15161,7 +15161,7 @@
           <a:ln/>
           <a:effectLst>
             <a:outerShdw sx="100000" sy="100000" kx="0" ky="0" algn="bl" rotWithShape="0" blurRad="101600" dist="25400" dir="5400000">
-              <a:srgbClr val="1B2A41">
+              <a:srgbClr val="0E2240">
                 <a:alpha val="12000"/>
               </a:srgbClr>
             </a:outerShdw>
@@ -15382,7 +15382,7 @@
           <a:ln/>
           <a:effectLst>
             <a:outerShdw sx="100000" sy="100000" kx="0" ky="0" algn="bl" rotWithShape="0" blurRad="101600" dist="25400" dir="5400000">
-              <a:srgbClr val="1B2A41">
+              <a:srgbClr val="0E2240">
                 <a:alpha val="12000"/>
               </a:srgbClr>
             </a:outerShdw>
@@ -15404,7 +15404,7 @@
             <a:avLst/>
           </a:prstGeom>
           <a:solidFill>
-            <a:schemeClr val="accent1"/>
+            <a:schemeClr val="accent5"/>
           </a:solidFill>
           <a:ln/>
         </p:spPr>
@@ -15460,7 +15460,7 @@
             <a:r>
               <a:rPr lang="en-US" sz="2200" b="1" dirty="0">
                 <a:solidFill>
-                  <a:schemeClr val="accent1"/>
+                  <a:schemeClr val="accent5"/>
                 </a:solidFill>
               </a:rPr>
               <a:t>Leave out</a:t>
@@ -15711,7 +15711,7 @@
           <a:ln/>
           <a:effectLst>
             <a:outerShdw sx="100000" sy="100000" kx="0" ky="0" algn="bl" rotWithShape="0" blurRad="101600" dist="25400" dir="5400000">
-              <a:srgbClr val="1B2A41">
+              <a:srgbClr val="0E2240">
                 <a:alpha val="12000"/>
               </a:srgbClr>
             </a:outerShdw>
@@ -15733,7 +15733,7 @@
             <a:avLst/>
           </a:prstGeom>
           <a:solidFill>
-            <a:schemeClr val="accent1"/>
+            <a:schemeClr val="accent5"/>
           </a:solidFill>
           <a:ln/>
         </p:spPr>
@@ -15789,7 +15789,7 @@
             <a:r>
               <a:rPr lang="en-US" sz="2200" b="1" dirty="0">
                 <a:solidFill>
-                  <a:schemeClr val="accent1"/>
+                  <a:schemeClr val="accent5"/>
                 </a:solidFill>
               </a:rPr>
               <a:t>Weak</a:t>
@@ -15861,7 +15861,7 @@
             <a:r>
               <a:rPr lang="en-US" sz="1400" dirty="0">
                 <a:solidFill>
-                  <a:schemeClr val="accent1"/>
+                  <a:schemeClr val="accent5"/>
                 </a:solidFill>
               </a:rPr>
               <a:t>Generic, about you, could be anyone</a:t>
@@ -15892,7 +15892,7 @@
           <a:ln/>
           <a:effectLst>
             <a:outerShdw sx="100000" sy="100000" kx="0" ky="0" algn="bl" rotWithShape="0" blurRad="101600" dist="25400" dir="5400000">
-              <a:srgbClr val="1B2A41">
+              <a:srgbClr val="0E2240">
                 <a:alpha val="12000"/>
               </a:srgbClr>
             </a:outerShdw>
@@ -16109,7 +16109,7 @@
   <a:themeElements>
     <a:clrScheme name="BugBoundQA">
       <a:dk1>
-        <a:srgbClr val="1B2A41"/>
+        <a:srgbClr val="0E2240"/>
       </a:dk1>
       <a:lt1>
         <a:srgbClr val="FFFFFF"/>
@@ -16118,13 +16118,13 @@
         <a:srgbClr val="3A506B"/>
       </a:dk2>
       <a:lt2>
-        <a:srgbClr val="EEF3F7"/>
+        <a:srgbClr val="EEF4FA"/>
       </a:lt2>
       <a:accent1>
-        <a:srgbClr val="E4572E"/>
+        <a:srgbClr val="1E5AA8"/>
       </a:accent1>
       <a:accent2>
-        <a:srgbClr val="17A398"/>
+        <a:srgbClr val="1688C6"/>
       </a:accent2>
       <a:accent3>
         <a:srgbClr val="F3A712"/>
@@ -16133,13 +16133,13 @@
         <a:srgbClr val="6C8EAD"/>
       </a:accent4>
       <a:accent5>
-        <a:srgbClr val="2E4057"/>
+        <a:srgbClr val="D64545"/>
       </a:accent5>
       <a:accent6>
-        <a:srgbClr val="FBE3DB"/>
+        <a:srgbClr val="DCEBF8"/>
       </a:accent6>
       <a:hlink>
-        <a:srgbClr val="17A398"/>
+        <a:srgbClr val="1688C6"/>
       </a:hlink>
       <a:folHlink>
         <a:srgbClr val="6C8EAD"/>

</xml_diff>